<commit_message>
Add per-slide hashing and cache lookup
Compute and store SHA-256 hashes per slide and use them for cache lookups before generating PPTX. Adds hash_slide/hash_slides and TEMPLATE_DIR to services.hash_service, a find_by_slide_hashes query in repositories.skeleton_repository, and updates services.skeleton_service to compute slide_hashes, check the repository for an exact slide-order+per-slide-hash match, and include slide_hashes in stored metadata. Tests updated to mock per-slide hashing, verify cache hits skip generation, and ensure slide_hashes are preserved. Also includes updated template and newly generated PPTX artifacts.
</commit_message>
<xml_diff>
--- a/storage/templates/Front slide.pptx
+++ b/storage/templates/Front slide.pptx
@@ -215,7 +215,7 @@
           <a:p>
             <a:fld id="{5FC0FD2D-0C03-B54E-81D5-A213644F7A74}" type="datetimeFigureOut">
               <a:rPr lang="nl-NL" smtClean="0"/>
-              <a:t>5-11-2025</a:t>
+              <a:t>09-03-2026</a:t>
             </a:fld>
             <a:endParaRPr lang="nl-NL"/>
           </a:p>
@@ -293,7 +293,7 @@
           <a:p>
             <a:fld id="{4247FC77-A562-2044-B0CB-DAD9705F10D7}" type="slidenum">
               <a:rPr lang="nl-NL" smtClean="0"/>
-              <a:t>‹nr.›</a:t>
+              <a:t>‹#›</a:t>
             </a:fld>
             <a:endParaRPr lang="nl-NL"/>
           </a:p>
@@ -392,7 +392,7 @@
           <a:p>
             <a:fld id="{FB53EA4F-706F-A846-AF35-5D3190B89244}" type="datetimeFigureOut">
               <a:rPr lang="nl-NL" smtClean="0"/>
-              <a:t>5-11-2025</a:t>
+              <a:t>09-03-2026</a:t>
             </a:fld>
             <a:endParaRPr lang="nl-NL"/>
           </a:p>
@@ -550,7 +550,7 @@
           <a:p>
             <a:fld id="{DA2EB03D-5C1B-924A-855A-C3EFA393BE91}" type="slidenum">
               <a:rPr lang="nl-NL" smtClean="0"/>
-              <a:t>‹nr.›</a:t>
+              <a:t>‹#›</a:t>
             </a:fld>
             <a:endParaRPr lang="nl-NL"/>
           </a:p>
@@ -1253,7 +1253,7 @@
             </a:pPr>
             <a:fld id="{00000000-1234-1234-1234-123412341234}" type="slidenum">
               <a:rPr lang="nl-NL"/>
-              <a:t>‹nr.›</a:t>
+              <a:t>‹#›</a:t>
             </a:fld>
             <a:endParaRPr/>
           </a:p>
@@ -3525,7 +3525,7 @@
             </a:pPr>
             <a:fld id="{00000000-1234-1234-1234-123412341234}" type="slidenum">
               <a:rPr lang="nl-NL"/>
-              <a:t>‹nr.›</a:t>
+              <a:t>‹#›</a:t>
             </a:fld>
             <a:endParaRPr/>
           </a:p>
@@ -5797,7 +5797,7 @@
             </a:pPr>
             <a:fld id="{00000000-1234-1234-1234-123412341234}" type="slidenum">
               <a:rPr lang="nl-NL"/>
-              <a:t>‹nr.›</a:t>
+              <a:t>‹#›</a:t>
             </a:fld>
             <a:endParaRPr/>
           </a:p>
@@ -8069,7 +8069,7 @@
             </a:pPr>
             <a:fld id="{00000000-1234-1234-1234-123412341234}" type="slidenum">
               <a:rPr lang="nl-NL"/>
-              <a:t>‹nr.›</a:t>
+              <a:t>‹#›</a:t>
             </a:fld>
             <a:endParaRPr/>
           </a:p>
@@ -10712,7 +10712,7 @@
             </a:pPr>
             <a:fld id="{00000000-1234-1234-1234-123412341234}" type="slidenum">
               <a:rPr lang="nl-NL"/>
-              <a:t>‹nr.›</a:t>
+              <a:t>‹#›</a:t>
             </a:fld>
             <a:endParaRPr/>
           </a:p>
@@ -11088,7 +11088,7 @@
             </a:pPr>
             <a:fld id="{00000000-1234-1234-1234-123412341234}" type="slidenum">
               <a:rPr lang="nl-NL"/>
-              <a:t>‹nr.›</a:t>
+              <a:t>‹#›</a:t>
             </a:fld>
             <a:endParaRPr/>
           </a:p>
@@ -11435,7 +11435,7 @@
             </a:pPr>
             <a:fld id="{00000000-1234-1234-1234-123412341234}" type="slidenum">
               <a:rPr lang="nl-NL"/>
-              <a:t>‹nr.›</a:t>
+              <a:t>‹#›</a:t>
             </a:fld>
             <a:endParaRPr/>
           </a:p>
@@ -12372,7 +12372,7 @@
             </a:pPr>
             <a:fld id="{00000000-1234-1234-1234-123412341234}" type="slidenum">
               <a:rPr lang="nl-NL"/>
-              <a:t>‹nr.›</a:t>
+              <a:t>‹#›</a:t>
             </a:fld>
             <a:endParaRPr/>
           </a:p>
@@ -13849,7 +13849,7 @@
             </a:pPr>
             <a:fld id="{00000000-1234-1234-1234-123412341234}" type="slidenum">
               <a:rPr lang="nl-NL"/>
-              <a:t>‹nr.›</a:t>
+              <a:t>‹#›</a:t>
             </a:fld>
             <a:endParaRPr/>
           </a:p>
@@ -15297,7 +15297,7 @@
             </a:pPr>
             <a:fld id="{00000000-1234-1234-1234-123412341234}" type="slidenum">
               <a:rPr lang="nl-NL"/>
-              <a:t>‹nr.›</a:t>
+              <a:t>‹#›</a:t>
             </a:fld>
             <a:endParaRPr/>
           </a:p>
@@ -16774,7 +16774,7 @@
             </a:pPr>
             <a:fld id="{00000000-1234-1234-1234-123412341234}" type="slidenum">
               <a:rPr lang="nl-NL"/>
-              <a:t>‹nr.›</a:t>
+              <a:t>‹#›</a:t>
             </a:fld>
             <a:endParaRPr/>
           </a:p>
@@ -18679,7 +18679,7 @@
             </a:pPr>
             <a:fld id="{00000000-1234-1234-1234-123412341234}" type="slidenum">
               <a:rPr lang="nl-NL"/>
-              <a:t>‹nr.›</a:t>
+              <a:t>‹#›</a:t>
             </a:fld>
             <a:endParaRPr/>
           </a:p>
@@ -20586,7 +20586,7 @@
             </a:pPr>
             <a:fld id="{00000000-1234-1234-1234-123412341234}" type="slidenum">
               <a:rPr lang="nl-NL"/>
-              <a:t>‹nr.›</a:t>
+              <a:t>‹#›</a:t>
             </a:fld>
             <a:endParaRPr/>
           </a:p>
@@ -22493,7 +22493,7 @@
             </a:pPr>
             <a:fld id="{00000000-1234-1234-1234-123412341234}" type="slidenum">
               <a:rPr lang="nl-NL"/>
-              <a:t>‹nr.›</a:t>
+              <a:t>‹#›</a:t>
             </a:fld>
             <a:endParaRPr/>
           </a:p>
@@ -24400,7 +24400,7 @@
             </a:pPr>
             <a:fld id="{00000000-1234-1234-1234-123412341234}" type="slidenum">
               <a:rPr lang="nl-NL"/>
-              <a:t>‹nr.›</a:t>
+              <a:t>‹#›</a:t>
             </a:fld>
             <a:endParaRPr/>
           </a:p>
@@ -26455,7 +26455,7 @@
           <a:p>
             <a:fld id="{4FA84005-1036-294C-BEFB-BC4118D190F1}" type="datetimeFigureOut">
               <a:rPr lang="nl-NL" smtClean="0"/>
-              <a:t>5-11-2025</a:t>
+              <a:t>09-03-2026</a:t>
             </a:fld>
             <a:endParaRPr lang="nl-NL"/>
           </a:p>
@@ -26533,7 +26533,7 @@
           <a:p>
             <a:fld id="{C3DCE6ED-1243-9B4D-AE75-3F9D6737CADD}" type="slidenum">
               <a:rPr lang="nl-NL" smtClean="0"/>
-              <a:t>‹nr.›</a:t>
+              <a:t>‹#›</a:t>
             </a:fld>
             <a:endParaRPr lang="nl-NL"/>
           </a:p>
@@ -26986,20 +26986,21 @@
               </a:rPr>
             </a:br>
             <a:r>
-              <a:rPr lang="nl-NL" sz="1600" dirty="0" err="1">
+              <a:rPr lang="nl-NL" sz="1600">
                 <a:solidFill>
                   <a:schemeClr val="lt1"/>
                 </a:solidFill>
                 <a:latin typeface="Avenir Book" panose="02000503020000020003" pitchFamily="2" charset="0"/>
                 <a:sym typeface="Avenir"/>
               </a:rPr>
-              <a:t>PHwaveperiod</a:t>
+              <a:t>Phwaveperiod</a:t>
             </a:r>
-            <a:endParaRPr lang="nl-NL" sz="3200" dirty="0">
+            <a:endParaRPr lang="nl-NL" sz="1600" dirty="0">
               <a:solidFill>
                 <a:schemeClr val="lt1"/>
               </a:solidFill>
               <a:latin typeface="Avenir Book" panose="02000503020000020003" pitchFamily="2" charset="0"/>
+              <a:sym typeface="Avenir"/>
             </a:endParaRPr>
           </a:p>
         </p:txBody>

</xml_diff>